<commit_message>
fix(presentacion): aclara las páginas 4, 5, 6 y 8 y actualiza el PDF de Canva
Las correcciones quedaron guardadas en Canva y exportadas al PDF nativo. Se actualizan las copias automáticas, la referencia del diseño y el manifiesto de entrega.
</commit_message>
<xml_diff>
--- a/documentacion/presentacion/canva/presentacion.pptx
+++ b/documentacion/presentacion/canva/presentacion.pptx
@@ -16538,6 +16538,48 @@
           </a:p>
         </p:txBody>
       </p:sp>
+      <p:sp>
+        <p:nvSpPr>
+          <p:cNvPr id="17" name="TextBox 16"/>
+          <p:cNvSpPr txBox="1"/>
+          <p:nvPr/>
+        </p:nvSpPr>
+        <p:spPr>
+          <a:xfrm>
+            <a:off x="1005840" y="5394960"/>
+            <a:ext cx="9875520" cy="594360"/>
+          </a:xfrm>
+          <a:prstGeom prst="rect">
+            <a:avLst/>
+          </a:prstGeom>
+          <a:noFill/>
+        </p:spPr>
+        <p:txBody>
+          <a:bodyPr wrap="square" lIns="0" rIns="0" tIns="0" bIns="0" anchor="ctr">
+            <a:spAutoFit/>
+          </a:bodyPr>
+          <a:lstStyle/>
+          <a:p>
+            <a:pPr algn="l">
+              <a:spcBef>
+                <a:spcPts val="0"/>
+              </a:spcBef>
+              <a:spcAft>
+                <a:spcPts val="0"/>
+              </a:spcAft>
+            </a:pPr>
+            <a:r>
+              <a:rPr sz="1400" b="0">
+                <a:solidFill>
+                  <a:srgbClr val="64748B"/>
+                </a:solidFill>
+                <a:latin typeface="Arial"/>
+              </a:rPr>
+              <a:t>Búsqueda con 50.000 filas; reajuste final sobre las 198.608 filas de entrenamiento, con el submuestreo correspondiente a cada condición.</a:t>
+            </a:r>
+          </a:p>
+        </p:txBody>
+      </p:sp>
     </p:spTree>
   </p:cSld>
   <p:clrMapOvr>
@@ -16685,7 +16727,7 @@
                 </a:solidFill>
                 <a:latin typeface="Arial"/>
               </a:rPr>
-              <a:t>Cada clasificador se prueba sin compensación y con submuestreo 1:10.</a:t>
+              <a:t>Dos condiciones: sin compensación y submuestreo de 1 fraude por cada 10 legítimas.</a:t>
             </a:r>
           </a:p>
         </p:txBody>
@@ -17733,7 +17775,7 @@
                 </a:solidFill>
                 <a:latin typeface="Arial"/>
               </a:rPr>
-              <a:t>ANOVA F es marginal y rápido; fijamos top 20. El submuestreo conserva fraudes y reduce el costo de train, pero descarta legítimas. Escalar importa para distancias y regularización.</a:t>
+              <a:t>Seleccionamos las 20 variables con mayor puntuación ANOVA F, un criterio marginal. El submuestreo conserva fraudes, pero descarta legítimas. Escalar importa para distancias y regularización.</a:t>
             </a:r>
           </a:p>
         </p:txBody>
@@ -18165,7 +18207,7 @@
                 </a:solidFill>
                 <a:latin typeface="Arial"/>
               </a:rPr>
-              <a:t>Cada árbol recibe una muestra del tamaño del train, con reemplazo.</a:t>
+              <a:t>Muestra con reemplazo, del tamaño del train de cada condición; ya submuestreado cuando corresponde.</a:t>
             </a:r>
           </a:p>
         </p:txBody>
@@ -18445,7 +18487,7 @@
                 </a:solidFill>
                 <a:latin typeface="Arial"/>
               </a:rPr>
-              <a:t>fit() / predict()</a:t>
+              <a:t>Legítima o fraude</a:t>
             </a:r>
           </a:p>
         </p:txBody>
@@ -18487,7 +18529,7 @@
                 </a:solidFill>
                 <a:latin typeface="Arial"/>
               </a:rPr>
-              <a:t>predict suma votos; el empate favorece fraude.</a:t>
+              <a:t>predict suma los votos de los árboles; el empate favorece fraude. fit y predict están separados.</a:t>
             </a:r>
           </a:p>
         </p:txBody>
@@ -19889,7 +19931,7 @@
         <p:spPr>
           <a:xfrm>
             <a:off x="2240280" y="1874691"/>
-            <a:ext cx="6565492" cy="213626"/>
+            <a:ext cx="5912570" cy="213626"/>
           </a:xfrm>
           <a:prstGeom prst="rect">
             <a:avLst/>
@@ -19931,8 +19973,8 @@
         </p:nvSpPr>
         <p:spPr>
           <a:xfrm>
-            <a:off x="10588752" y="1746504"/>
-            <a:ext cx="1143000" cy="490347"/>
+            <a:off x="9765792" y="1746504"/>
+            <a:ext cx="1508760" cy="490347"/>
           </a:xfrm>
           <a:prstGeom prst="rect">
             <a:avLst/>
@@ -20016,7 +20058,7 @@
         <p:spPr>
           <a:xfrm>
             <a:off x="2240280" y="2383326"/>
-            <a:ext cx="7167887" cy="213626"/>
+            <a:ext cx="6455058" cy="213626"/>
           </a:xfrm>
           <a:prstGeom prst="rect">
             <a:avLst/>
@@ -20058,8 +20100,8 @@
         </p:nvSpPr>
         <p:spPr>
           <a:xfrm>
-            <a:off x="10588752" y="2255138"/>
-            <a:ext cx="1143000" cy="490347"/>
+            <a:off x="9765792" y="2255138"/>
+            <a:ext cx="1508760" cy="490347"/>
           </a:xfrm>
           <a:prstGeom prst="rect">
             <a:avLst/>
@@ -20143,7 +20185,7 @@
         <p:spPr>
           <a:xfrm>
             <a:off x="2240280" y="2891961"/>
-            <a:ext cx="5762300" cy="213626"/>
+            <a:ext cx="5189253" cy="213626"/>
           </a:xfrm>
           <a:prstGeom prst="rect">
             <a:avLst/>
@@ -20185,8 +20227,8 @@
         </p:nvSpPr>
         <p:spPr>
           <a:xfrm>
-            <a:off x="10588752" y="2763774"/>
-            <a:ext cx="1143000" cy="490347"/>
+            <a:off x="9765792" y="2763774"/>
+            <a:ext cx="1508760" cy="490347"/>
           </a:xfrm>
           <a:prstGeom prst="rect">
             <a:avLst/>
@@ -20270,7 +20312,7 @@
         <p:spPr>
           <a:xfrm>
             <a:off x="2240280" y="3400596"/>
-            <a:ext cx="7070530" cy="213626"/>
+            <a:ext cx="6367384" cy="213626"/>
           </a:xfrm>
           <a:prstGeom prst="rect">
             <a:avLst/>
@@ -20312,8 +20354,8 @@
         </p:nvSpPr>
         <p:spPr>
           <a:xfrm>
-            <a:off x="10588752" y="3272409"/>
-            <a:ext cx="1143000" cy="490347"/>
+            <a:off x="9765792" y="3272409"/>
+            <a:ext cx="1508760" cy="490347"/>
           </a:xfrm>
           <a:prstGeom prst="rect">
             <a:avLst/>
@@ -20397,7 +20439,7 @@
         <p:spPr>
           <a:xfrm>
             <a:off x="2240280" y="3909231"/>
-            <a:ext cx="4855665" cy="213626"/>
+            <a:ext cx="4372781" cy="213626"/>
           </a:xfrm>
           <a:prstGeom prst="rect">
             <a:avLst/>
@@ -20439,8 +20481,8 @@
         </p:nvSpPr>
         <p:spPr>
           <a:xfrm>
-            <a:off x="10588752" y="3781044"/>
-            <a:ext cx="1143000" cy="490347"/>
+            <a:off x="9765792" y="3781044"/>
+            <a:ext cx="1508760" cy="490347"/>
           </a:xfrm>
           <a:prstGeom prst="rect">
             <a:avLst/>
@@ -20524,7 +20566,7 @@
         <p:spPr>
           <a:xfrm>
             <a:off x="2240280" y="4417866"/>
-            <a:ext cx="7161802" cy="213626"/>
+            <a:ext cx="6449579" cy="213626"/>
           </a:xfrm>
           <a:prstGeom prst="rect">
             <a:avLst/>
@@ -20566,8 +20608,8 @@
         </p:nvSpPr>
         <p:spPr>
           <a:xfrm>
-            <a:off x="10588752" y="4289679"/>
-            <a:ext cx="1143000" cy="490347"/>
+            <a:off x="9765792" y="4289679"/>
+            <a:ext cx="1508760" cy="490347"/>
           </a:xfrm>
           <a:prstGeom prst="rect">
             <a:avLst/>
@@ -20651,7 +20693,7 @@
         <p:spPr>
           <a:xfrm>
             <a:off x="2240280" y="4926501"/>
-            <a:ext cx="6151726" cy="213626"/>
+            <a:ext cx="5539952" cy="213626"/>
           </a:xfrm>
           <a:prstGeom prst="rect">
             <a:avLst/>
@@ -20693,8 +20735,8 @@
         </p:nvSpPr>
         <p:spPr>
           <a:xfrm>
-            <a:off x="10588752" y="4798314"/>
-            <a:ext cx="1143000" cy="490347"/>
+            <a:off x="9765792" y="4798314"/>
+            <a:ext cx="1508760" cy="490347"/>
           </a:xfrm>
           <a:prstGeom prst="rect">
             <a:avLst/>
@@ -20778,7 +20820,7 @@
         <p:spPr>
           <a:xfrm>
             <a:off x="2240280" y="5435136"/>
-            <a:ext cx="7271328" cy="213626"/>
+            <a:ext cx="6548213" cy="213626"/>
           </a:xfrm>
           <a:prstGeom prst="rect">
             <a:avLst/>
@@ -20820,8 +20862,8 @@
         </p:nvSpPr>
         <p:spPr>
           <a:xfrm>
-            <a:off x="10588752" y="5306949"/>
-            <a:ext cx="1143000" cy="490347"/>
+            <a:off x="9765792" y="5306949"/>
+            <a:ext cx="1508760" cy="490347"/>
           </a:xfrm>
           <a:prstGeom prst="rect">
             <a:avLst/>
@@ -20863,7 +20905,7 @@
         <p:spPr>
           <a:xfrm>
             <a:off x="2240280" y="5824727"/>
-            <a:ext cx="8275320" cy="164592"/>
+            <a:ext cx="7452360" cy="164592"/>
           </a:xfrm>
           <a:prstGeom prst="rect">
             <a:avLst/>
@@ -20933,7 +20975,7 @@
                 </a:solidFill>
                 <a:latin typeface="Arial"/>
               </a:rPr>
-              <a:t>Selección por sensibilidad media; precisión media resuelve empates.</a:t>
+              <a:t>Mayor media observada; no demuestra superioridad estadística. La precisión desempata.</a:t>
             </a:r>
           </a:p>
         </p:txBody>

</xml_diff>